<commit_message>
⎕EM don't need each
</commit_message>
<xml_diff>
--- a/slides/APL_Bootcamp-part-10-errors.pptx
+++ b/slides/APL_Bootcamp-part-10-errors.pptx
@@ -276,7 +276,7 @@
               <a:rPr lang="en-GB" smtClean="0">
                 <a:latin typeface="Sarabun" panose="00000500000000000000" pitchFamily="2" charset="-34"/>
               </a:rPr>
-              <a:t>20/08/2025</a:t>
+              <a:t>16/09/2025</a:t>
             </a:fld>
             <a:endParaRPr lang="en-GB" dirty="0">
               <a:latin typeface="Sarabun" panose="00000500000000000000" pitchFamily="2" charset="-34"/>
@@ -454,7 +454,7 @@
             <a:fld id="{CDEAEF8A-5BB8-41C8-B8C2-160617C17EF4}" type="datetimeFigureOut">
               <a:rPr lang="en-GB" smtClean="0"/>
               <a:pPr/>
-              <a:t>20/08/2025</a:t>
+              <a:t>16/09/2025</a:t>
             </a:fld>
             <a:endParaRPr lang="en-GB" dirty="0"/>
           </a:p>
@@ -10218,25 +10218,7 @@
                 </a:solidFill>
                 <a:latin typeface="APL385 Unicode" panose="020B0709000202000203" pitchFamily="49" charset="0"/>
               </a:rPr>
-              <a:t>⍪⎕</a:t>
-            </a:r>
-            <a:r>
-              <a:rPr lang="en-GB" dirty="0" err="1">
-                <a:solidFill>
-                  <a:srgbClr val="00B050"/>
-                </a:solidFill>
-                <a:latin typeface="APL385 Unicode" panose="020B0709000202000203" pitchFamily="49" charset="0"/>
-              </a:rPr>
-              <a:t>em</a:t>
-            </a:r>
-            <a:r>
-              <a:rPr lang="en-GB" dirty="0">
-                <a:solidFill>
-                  <a:srgbClr val="00B050"/>
-                </a:solidFill>
-                <a:latin typeface="APL385 Unicode" panose="020B0709000202000203" pitchFamily="49" charset="0"/>
-              </a:rPr>
-              <a:t>¨⍳99</a:t>
+              <a:t>⍪⎕EM⍳99</a:t>
             </a:r>
           </a:p>
           <a:p>

</xml_diff>